<commit_message>
updated presentation and views
</commit_message>
<xml_diff>
--- a/presentation/legoarch-deck.pptx
+++ b/presentation/legoarch-deck.pptx
@@ -9202,6 +9202,45 @@
         </p:nvSpPr>
         <p:spPr>
           <a:xfrm>
+            <a:off x="3041827" y="3751325"/>
+            <a:ext cx="1658070" cy="274320"/>
+          </a:xfrm>
+          <a:prstGeom prst="rect">
+            <a:avLst/>
+          </a:prstGeom>
+          <a:noFill/>
+        </p:spPr>
+        <p:txBody>
+          <a:bodyPr wrap="square" tIns="0" bIns="0" lIns="0" rIns="0" anchor="t">
+            <a:spAutoFit/>
+          </a:bodyPr>
+          <a:lstStyle/>
+          <a:p>
+            <a:pPr algn="ctr">
+              <a:lnSpc>
+                <a:spcPct val="130000"/>
+              </a:lnSpc>
+            </a:pPr>
+            <a:r>
+              <a:rPr sz="1100" b="0">
+                <a:solidFill>
+                  <a:srgbClr val="A59C8C"/>
+                </a:solidFill>
+                <a:latin typeface="DM Sans"/>
+              </a:rPr>
+              <a:t>image</a:t>
+            </a:r>
+          </a:p>
+        </p:txBody>
+      </p:sp>
+      <p:sp>
+        <p:nvSpPr>
+          <p:cNvPr id="12" name="TextBox 11"/>
+          <p:cNvSpPr txBox="1"/>
+          <p:nvPr/>
+        </p:nvSpPr>
+        <p:spPr>
+          <a:xfrm>
             <a:off x="3041827" y="4169663"/>
             <a:ext cx="1658070" cy="342900"/>
           </a:xfrm>
@@ -9235,7 +9274,7 @@
       </p:sp>
       <p:sp>
         <p:nvSpPr>
-          <p:cNvPr id="12" name="TextBox 11"/>
+          <p:cNvPr id="13" name="TextBox 12"/>
           <p:cNvSpPr txBox="1"/>
           <p:nvPr/>
         </p:nvSpPr>
@@ -9274,7 +9313,7 @@
       </p:sp>
       <p:sp>
         <p:nvSpPr>
-          <p:cNvPr id="13" name="TextBox 12"/>
+          <p:cNvPr id="14" name="TextBox 13"/>
           <p:cNvSpPr txBox="1"/>
           <p:nvPr/>
         </p:nvSpPr>
@@ -9313,7 +9352,7 @@
       </p:sp>
       <p:sp>
         <p:nvSpPr>
-          <p:cNvPr id="14" name="TextBox 13"/>
+          <p:cNvPr id="15" name="TextBox 14"/>
           <p:cNvSpPr txBox="1"/>
           <p:nvPr/>
         </p:nvSpPr>
@@ -9352,7 +9391,7 @@
       </p:sp>
       <p:sp>
         <p:nvSpPr>
-          <p:cNvPr id="15" name="TextBox 14"/>
+          <p:cNvPr id="16" name="TextBox 15"/>
           <p:cNvSpPr txBox="1"/>
           <p:nvPr/>
         </p:nvSpPr>
@@ -9391,7 +9430,7 @@
       </p:sp>
       <p:sp>
         <p:nvSpPr>
-          <p:cNvPr id="16" name="TextBox 15"/>
+          <p:cNvPr id="17" name="TextBox 16"/>
           <p:cNvSpPr txBox="1"/>
           <p:nvPr/>
         </p:nvSpPr>
@@ -9430,7 +9469,7 @@
       </p:sp>
       <p:sp>
         <p:nvSpPr>
-          <p:cNvPr id="17" name="TextBox 16"/>
+          <p:cNvPr id="18" name="TextBox 17"/>
           <p:cNvSpPr txBox="1"/>
           <p:nvPr/>
         </p:nvSpPr>
@@ -9469,7 +9508,7 @@
       </p:sp>
       <p:sp>
         <p:nvSpPr>
-          <p:cNvPr id="18" name="TextBox 17"/>
+          <p:cNvPr id="19" name="TextBox 18"/>
           <p:cNvSpPr txBox="1"/>
           <p:nvPr/>
         </p:nvSpPr>
@@ -9508,7 +9547,7 @@
       </p:sp>
       <p:sp>
         <p:nvSpPr>
-          <p:cNvPr id="19" name="TextBox 18"/>
+          <p:cNvPr id="20" name="TextBox 19"/>
           <p:cNvSpPr txBox="1"/>
           <p:nvPr/>
         </p:nvSpPr>
@@ -9547,7 +9586,7 @@
       </p:sp>
       <p:sp>
         <p:nvSpPr>
-          <p:cNvPr id="20" name="TextBox 19"/>
+          <p:cNvPr id="21" name="TextBox 20"/>
           <p:cNvSpPr txBox="1"/>
           <p:nvPr/>
         </p:nvSpPr>
@@ -9586,7 +9625,7 @@
       </p:sp>
       <p:sp>
         <p:nvSpPr>
-          <p:cNvPr id="21" name="TextBox 20"/>
+          <p:cNvPr id="22" name="TextBox 21"/>
           <p:cNvSpPr txBox="1"/>
           <p:nvPr/>
         </p:nvSpPr>
@@ -9625,7 +9664,7 @@
       </p:sp>
       <p:sp>
         <p:nvSpPr>
-          <p:cNvPr id="22" name="TextBox 21"/>
+          <p:cNvPr id="23" name="TextBox 22"/>
           <p:cNvSpPr txBox="1"/>
           <p:nvPr/>
         </p:nvSpPr>

</xml_diff>